<commit_message>
Actividad unica del Corte 2 en ARQ: 12 preguntas para las Clases 6-10
Co-Authored-By: Claude Opus 5 <noreply@anthropic.com>
</commit_message>
<xml_diff>
--- a/Arquitectura de Sistemas Computacionales/Clases/Clase 10 - Costos y sostenibilidad cloud/Presentacion.pptx
+++ b/Arquitectura de Sistemas Computacionales/Clases/Clase 10 - Costos y sostenibilidad cloud/Presentacion.pptx
@@ -15,7 +15,6 @@
     <p:sldId id="263" r:id="rId14"/>
     <p:sldId id="264" r:id="rId15"/>
     <p:sldId id="265" r:id="rId16"/>
-    <p:sldId id="266" r:id="rId17"/>
   </p:sldIdLst>
   <p:sldSz cx="12191695" cy="6858000" type="screen4x3"/>
   <p:notesSz cx="6858000" cy="9144000"/>
@@ -3468,601 +3467,6 @@
         <p:spPr>
           <a:xfrm>
             <a:off x="0" y="0"/>
-            <a:ext cx="12191695" cy="960120"/>
-          </a:xfrm>
-          <a:prstGeom prst="rect">
-            <a:avLst/>
-          </a:prstGeom>
-          <a:solidFill>
-            <a:srgbClr val="095292"/>
-          </a:solidFill>
-          <a:ln>
-            <a:noFill/>
-          </a:ln>
-        </p:spPr>
-        <p:style>
-          <a:lnRef idx="1">
-            <a:schemeClr val="accent1"/>
-          </a:lnRef>
-          <a:fillRef idx="3">
-            <a:schemeClr val="accent1"/>
-          </a:fillRef>
-          <a:effectRef idx="2">
-            <a:schemeClr val="accent1"/>
-          </a:effectRef>
-          <a:fontRef idx="minor">
-            <a:schemeClr val="lt1"/>
-          </a:fontRef>
-        </p:style>
-        <p:txBody>
-          <a:bodyPr rtlCol="0" anchor="ctr"/>
-          <a:lstStyle/>
-          <a:p>
-            <a:pPr algn="ctr"/>
-          </a:p>
-        </p:txBody>
-      </p:sp>
-      <p:sp>
-        <p:nvSpPr>
-          <p:cNvPr id="3" name="Rectangle 2"/>
-          <p:cNvSpPr/>
-          <p:nvPr/>
-        </p:nvSpPr>
-        <p:spPr>
-          <a:xfrm>
-            <a:off x="0" y="960120"/>
-            <a:ext cx="12191695" cy="41148"/>
-          </a:xfrm>
-          <a:prstGeom prst="rect">
-            <a:avLst/>
-          </a:prstGeom>
-          <a:solidFill>
-            <a:srgbClr val="FFD000"/>
-          </a:solidFill>
-          <a:ln>
-            <a:noFill/>
-          </a:ln>
-        </p:spPr>
-        <p:style>
-          <a:lnRef idx="1">
-            <a:schemeClr val="accent1"/>
-          </a:lnRef>
-          <a:fillRef idx="3">
-            <a:schemeClr val="accent1"/>
-          </a:fillRef>
-          <a:effectRef idx="2">
-            <a:schemeClr val="accent1"/>
-          </a:effectRef>
-          <a:fontRef idx="minor">
-            <a:schemeClr val="lt1"/>
-          </a:fontRef>
-        </p:style>
-        <p:txBody>
-          <a:bodyPr rtlCol="0" anchor="ctr"/>
-          <a:lstStyle/>
-          <a:p>
-            <a:pPr algn="ctr"/>
-          </a:p>
-        </p:txBody>
-      </p:sp>
-      <p:sp>
-        <p:nvSpPr>
-          <p:cNvPr id="4" name="TextBox 3"/>
-          <p:cNvSpPr txBox="1"/>
-          <p:nvPr/>
-        </p:nvSpPr>
-        <p:spPr>
-          <a:xfrm>
-            <a:off x="457200" y="164592"/>
-            <a:ext cx="11277295" cy="502920"/>
-          </a:xfrm>
-          <a:prstGeom prst="rect">
-            <a:avLst/>
-          </a:prstGeom>
-          <a:noFill/>
-        </p:spPr>
-        <p:txBody>
-          <a:bodyPr wrap="square">
-            <a:spAutoFit/>
-          </a:bodyPr>
-          <a:lstStyle/>
-          <a:p>
-            <a:r>
-              <a:rPr sz="2600" b="1" i="0">
-                <a:solidFill>
-                  <a:srgbClr val="FFFFFF"/>
-                </a:solidFill>
-                <a:latin typeface="Calibri"/>
-              </a:rPr>
-              <a:t>Para continuar (PI)</a:t>
-            </a:r>
-          </a:p>
-        </p:txBody>
-      </p:sp>
-      <p:sp>
-        <p:nvSpPr>
-          <p:cNvPr id="5" name="Rounded Rectangle 4"/>
-          <p:cNvSpPr/>
-          <p:nvPr/>
-        </p:nvSpPr>
-        <p:spPr>
-          <a:xfrm>
-            <a:off x="457200" y="1261872"/>
-            <a:ext cx="11277295" cy="1051560"/>
-          </a:xfrm>
-          <a:prstGeom prst="roundRect">
-            <a:avLst>
-              <a:gd name="adj" fmla="val 12000"/>
-            </a:avLst>
-          </a:prstGeom>
-          <a:solidFill>
-            <a:srgbClr val="E8F4FA"/>
-          </a:solidFill>
-          <a:ln>
-            <a:noFill/>
-          </a:ln>
-        </p:spPr>
-        <p:style>
-          <a:lnRef idx="1">
-            <a:schemeClr val="accent1"/>
-          </a:lnRef>
-          <a:fillRef idx="3">
-            <a:schemeClr val="accent1"/>
-          </a:fillRef>
-          <a:effectRef idx="2">
-            <a:schemeClr val="accent1"/>
-          </a:effectRef>
-          <a:fontRef idx="minor">
-            <a:schemeClr val="lt1"/>
-          </a:fontRef>
-        </p:style>
-        <p:txBody>
-          <a:bodyPr rtlCol="0" anchor="ctr"/>
-          <a:lstStyle/>
-          <a:p>
-            <a:pPr algn="ctr"/>
-          </a:p>
-        </p:txBody>
-      </p:sp>
-      <p:sp>
-        <p:nvSpPr>
-          <p:cNvPr id="6" name="Rectangle 5"/>
-          <p:cNvSpPr/>
-          <p:nvPr/>
-        </p:nvSpPr>
-        <p:spPr>
-          <a:xfrm>
-            <a:off x="457200" y="1261872"/>
-            <a:ext cx="128016" cy="1051560"/>
-          </a:xfrm>
-          <a:prstGeom prst="rect">
-            <a:avLst/>
-          </a:prstGeom>
-          <a:solidFill>
-            <a:srgbClr val="269CCB"/>
-          </a:solidFill>
-          <a:ln>
-            <a:noFill/>
-          </a:ln>
-        </p:spPr>
-        <p:style>
-          <a:lnRef idx="1">
-            <a:schemeClr val="accent1"/>
-          </a:lnRef>
-          <a:fillRef idx="3">
-            <a:schemeClr val="accent1"/>
-          </a:fillRef>
-          <a:effectRef idx="2">
-            <a:schemeClr val="accent1"/>
-          </a:effectRef>
-          <a:fontRef idx="minor">
-            <a:schemeClr val="lt1"/>
-          </a:fontRef>
-        </p:style>
-        <p:txBody>
-          <a:bodyPr rtlCol="0" anchor="ctr"/>
-          <a:lstStyle/>
-          <a:p>
-            <a:pPr algn="ctr"/>
-          </a:p>
-        </p:txBody>
-      </p:sp>
-      <p:sp>
-        <p:nvSpPr>
-          <p:cNvPr id="7" name="TextBox 6"/>
-          <p:cNvSpPr txBox="1"/>
-          <p:nvPr/>
-        </p:nvSpPr>
-        <p:spPr>
-          <a:xfrm>
-            <a:off x="777240" y="1399031"/>
-            <a:ext cx="10774375" cy="822959"/>
-          </a:xfrm>
-          <a:prstGeom prst="rect">
-            <a:avLst/>
-          </a:prstGeom>
-          <a:noFill/>
-        </p:spPr>
-        <p:txBody>
-          <a:bodyPr wrap="square">
-            <a:spAutoFit/>
-          </a:bodyPr>
-          <a:lstStyle/>
-          <a:p>
-            <a:r>
-              <a:rPr sz="1200" b="1" i="0">
-                <a:solidFill>
-                  <a:srgbClr val="269CCB"/>
-                </a:solidFill>
-                <a:latin typeface="Calibri"/>
-              </a:rPr>
-              <a:t>Info</a:t>
-            </a:r>
-          </a:p>
-          <a:p>
-            <a:pPr>
-              <a:spcBef>
-                <a:spcPts val="400"/>
-              </a:spcBef>
-            </a:pPr>
-            <a:r>
-              <a:rPr sz="1400" b="0" i="0">
-                <a:solidFill>
-                  <a:srgbClr val="333333"/>
-                </a:solidFill>
-                <a:latin typeface="Calibri"/>
-              </a:rPr>
-              <a:t>Entregable: Sección Costos/Sostenibilidad del informe (bajo/medio + drivers)</a:t>
-            </a:r>
-          </a:p>
-        </p:txBody>
-      </p:sp>
-      <p:sp>
-        <p:nvSpPr>
-          <p:cNvPr id="8" name="Rounded Rectangle 7"/>
-          <p:cNvSpPr/>
-          <p:nvPr/>
-        </p:nvSpPr>
-        <p:spPr>
-          <a:xfrm>
-            <a:off x="457200" y="2478024"/>
-            <a:ext cx="11277295" cy="1051560"/>
-          </a:xfrm>
-          <a:prstGeom prst="roundRect">
-            <a:avLst>
-              <a:gd name="adj" fmla="val 12000"/>
-            </a:avLst>
-          </a:prstGeom>
-          <a:solidFill>
-            <a:srgbClr val="FFF8E1"/>
-          </a:solidFill>
-          <a:ln>
-            <a:noFill/>
-          </a:ln>
-        </p:spPr>
-        <p:style>
-          <a:lnRef idx="1">
-            <a:schemeClr val="accent1"/>
-          </a:lnRef>
-          <a:fillRef idx="3">
-            <a:schemeClr val="accent1"/>
-          </a:fillRef>
-          <a:effectRef idx="2">
-            <a:schemeClr val="accent1"/>
-          </a:effectRef>
-          <a:fontRef idx="minor">
-            <a:schemeClr val="lt1"/>
-          </a:fontRef>
-        </p:style>
-        <p:txBody>
-          <a:bodyPr rtlCol="0" anchor="ctr"/>
-          <a:lstStyle/>
-          <a:p>
-            <a:pPr algn="ctr"/>
-          </a:p>
-        </p:txBody>
-      </p:sp>
-      <p:sp>
-        <p:nvSpPr>
-          <p:cNvPr id="9" name="Rectangle 8"/>
-          <p:cNvSpPr/>
-          <p:nvPr/>
-        </p:nvSpPr>
-        <p:spPr>
-          <a:xfrm>
-            <a:off x="457200" y="2478024"/>
-            <a:ext cx="128016" cy="1051560"/>
-          </a:xfrm>
-          <a:prstGeom prst="rect">
-            <a:avLst/>
-          </a:prstGeom>
-          <a:solidFill>
-            <a:srgbClr val="FFD000"/>
-          </a:solidFill>
-          <a:ln>
-            <a:noFill/>
-          </a:ln>
-        </p:spPr>
-        <p:style>
-          <a:lnRef idx="1">
-            <a:schemeClr val="accent1"/>
-          </a:lnRef>
-          <a:fillRef idx="3">
-            <a:schemeClr val="accent1"/>
-          </a:fillRef>
-          <a:effectRef idx="2">
-            <a:schemeClr val="accent1"/>
-          </a:effectRef>
-          <a:fontRef idx="minor">
-            <a:schemeClr val="lt1"/>
-          </a:fontRef>
-        </p:style>
-        <p:txBody>
-          <a:bodyPr rtlCol="0" anchor="ctr"/>
-          <a:lstStyle/>
-          <a:p>
-            <a:pPr algn="ctr"/>
-          </a:p>
-        </p:txBody>
-      </p:sp>
-      <p:sp>
-        <p:nvSpPr>
-          <p:cNvPr id="10" name="TextBox 9"/>
-          <p:cNvSpPr txBox="1"/>
-          <p:nvPr/>
-        </p:nvSpPr>
-        <p:spPr>
-          <a:xfrm>
-            <a:off x="777240" y="2615184"/>
-            <a:ext cx="10774375" cy="822959"/>
-          </a:xfrm>
-          <a:prstGeom prst="rect">
-            <a:avLst/>
-          </a:prstGeom>
-          <a:noFill/>
-        </p:spPr>
-        <p:txBody>
-          <a:bodyPr wrap="square">
-            <a:spAutoFit/>
-          </a:bodyPr>
-          <a:lstStyle/>
-          <a:p>
-            <a:r>
-              <a:rPr sz="1200" b="1" i="0">
-                <a:solidFill>
-                  <a:srgbClr val="FFD000"/>
-                </a:solidFill>
-                <a:latin typeface="Calibri"/>
-              </a:rPr>
-              <a:t>Aclaración</a:t>
-            </a:r>
-          </a:p>
-          <a:p>
-            <a:pPr>
-              <a:spcBef>
-                <a:spcPts val="400"/>
-              </a:spcBef>
-            </a:pPr>
-            <a:r>
-              <a:rPr sz="1400" b="0" i="0">
-                <a:solidFill>
-                  <a:srgbClr val="333333"/>
-                </a:solidFill>
-                <a:latin typeface="Calibri"/>
-              </a:rPr>
-              <a:t>Subir evidencias al paquete CloudLite (Drive/repo) y a ExamLab (https://uniaj.examlab.workers.dev/) domingo 23:59.</a:t>
-            </a:r>
-          </a:p>
-        </p:txBody>
-      </p:sp>
-      <p:sp>
-        <p:nvSpPr>
-          <p:cNvPr id="11" name="Rounded Rectangle 10"/>
-          <p:cNvSpPr/>
-          <p:nvPr/>
-        </p:nvSpPr>
-        <p:spPr>
-          <a:xfrm>
-            <a:off x="457200" y="3694176"/>
-            <a:ext cx="11277295" cy="1051560"/>
-          </a:xfrm>
-          <a:prstGeom prst="roundRect">
-            <a:avLst>
-              <a:gd name="adj" fmla="val 12000"/>
-            </a:avLst>
-          </a:prstGeom>
-          <a:solidFill>
-            <a:srgbClr val="FBE4E4"/>
-          </a:solidFill>
-          <a:ln>
-            <a:noFill/>
-          </a:ln>
-        </p:spPr>
-        <p:style>
-          <a:lnRef idx="1">
-            <a:schemeClr val="accent1"/>
-          </a:lnRef>
-          <a:fillRef idx="3">
-            <a:schemeClr val="accent1"/>
-          </a:fillRef>
-          <a:effectRef idx="2">
-            <a:schemeClr val="accent1"/>
-          </a:effectRef>
-          <a:fontRef idx="minor">
-            <a:schemeClr val="lt1"/>
-          </a:fontRef>
-        </p:style>
-        <p:txBody>
-          <a:bodyPr rtlCol="0" anchor="ctr"/>
-          <a:lstStyle/>
-          <a:p>
-            <a:pPr algn="ctr"/>
-          </a:p>
-        </p:txBody>
-      </p:sp>
-      <p:sp>
-        <p:nvSpPr>
-          <p:cNvPr id="12" name="Rectangle 11"/>
-          <p:cNvSpPr/>
-          <p:nvPr/>
-        </p:nvSpPr>
-        <p:spPr>
-          <a:xfrm>
-            <a:off x="457200" y="3694176"/>
-            <a:ext cx="128016" cy="1051560"/>
-          </a:xfrm>
-          <a:prstGeom prst="rect">
-            <a:avLst/>
-          </a:prstGeom>
-          <a:solidFill>
-            <a:srgbClr val="A02030"/>
-          </a:solidFill>
-          <a:ln>
-            <a:noFill/>
-          </a:ln>
-        </p:spPr>
-        <p:style>
-          <a:lnRef idx="1">
-            <a:schemeClr val="accent1"/>
-          </a:lnRef>
-          <a:fillRef idx="3">
-            <a:schemeClr val="accent1"/>
-          </a:fillRef>
-          <a:effectRef idx="2">
-            <a:schemeClr val="accent1"/>
-          </a:effectRef>
-          <a:fontRef idx="minor">
-            <a:schemeClr val="lt1"/>
-          </a:fontRef>
-        </p:style>
-        <p:txBody>
-          <a:bodyPr rtlCol="0" anchor="ctr"/>
-          <a:lstStyle/>
-          <a:p>
-            <a:pPr algn="ctr"/>
-          </a:p>
-        </p:txBody>
-      </p:sp>
-      <p:sp>
-        <p:nvSpPr>
-          <p:cNvPr id="13" name="TextBox 12"/>
-          <p:cNvSpPr txBox="1"/>
-          <p:nvPr/>
-        </p:nvSpPr>
-        <p:spPr>
-          <a:xfrm>
-            <a:off x="777240" y="3831336"/>
-            <a:ext cx="10774375" cy="822959"/>
-          </a:xfrm>
-          <a:prstGeom prst="rect">
-            <a:avLst/>
-          </a:prstGeom>
-          <a:noFill/>
-        </p:spPr>
-        <p:txBody>
-          <a:bodyPr wrap="square">
-            <a:spAutoFit/>
-          </a:bodyPr>
-          <a:lstStyle/>
-          <a:p>
-            <a:r>
-              <a:rPr sz="1200" b="1" i="0">
-                <a:solidFill>
-                  <a:srgbClr val="A02030"/>
-                </a:solidFill>
-                <a:latin typeface="Calibri"/>
-              </a:rPr>
-              <a:t>Atención</a:t>
-            </a:r>
-          </a:p>
-          <a:p>
-            <a:pPr>
-              <a:spcBef>
-                <a:spcPts val="400"/>
-              </a:spcBef>
-            </a:pPr>
-            <a:r>
-              <a:rPr sz="1400" b="0" i="0">
-                <a:solidFill>
-                  <a:srgbClr val="333333"/>
-                </a:solidFill>
-                <a:latin typeface="Calibri"/>
-              </a:rPr>
-              <a:t>Sin cloud de pago ni instalaciones obligatorias de hipervisores/Docker Desktop.</a:t>
-            </a:r>
-          </a:p>
-        </p:txBody>
-      </p:sp>
-      <p:sp>
-        <p:nvSpPr>
-          <p:cNvPr id="14" name="TextBox 13"/>
-          <p:cNvSpPr txBox="1"/>
-          <p:nvPr/>
-        </p:nvSpPr>
-        <p:spPr>
-          <a:xfrm>
-            <a:off x="11185855" y="6473952"/>
-            <a:ext cx="640080" cy="274320"/>
-          </a:xfrm>
-          <a:prstGeom prst="rect">
-            <a:avLst/>
-          </a:prstGeom>
-          <a:noFill/>
-        </p:spPr>
-        <p:txBody>
-          <a:bodyPr wrap="square">
-            <a:spAutoFit/>
-          </a:bodyPr>
-          <a:lstStyle/>
-          <a:p>
-            <a:pPr algn="r"/>
-            <a:r>
-              <a:rPr sz="1100" b="0" i="0">
-                <a:solidFill>
-                  <a:srgbClr val="666666"/>
-                </a:solidFill>
-                <a:latin typeface="Calibri"/>
-              </a:rPr>
-              <a:t>10</a:t>
-            </a:r>
-          </a:p>
-        </p:txBody>
-      </p:sp>
-    </p:spTree>
-  </p:cSld>
-  <p:clrMapOvr>
-    <a:masterClrMapping/>
-  </p:clrMapOvr>
-</p:sld>
-</file>
-
-<file path=ppt/slides/slide11.xml><?xml version="1.0" encoding="utf-8"?>
-<p:sld xmlns:a="http://schemas.openxmlformats.org/drawingml/2006/main" xmlns:p="http://schemas.openxmlformats.org/presentationml/2006/main" xmlns:r="http://schemas.openxmlformats.org/officeDocument/2006/relationships">
-  <p:cSld>
-    <p:bg>
-      <p:bgPr>
-        <a:solidFill>
-          <a:srgbClr val="FFFFFF"/>
-        </a:solidFill>
-        <a:effectLst/>
-      </p:bgPr>
-    </p:bg>
-    <p:spTree>
-      <p:nvGrpSpPr>
-        <p:cNvPr id="1" name=""/>
-        <p:cNvGrpSpPr/>
-        <p:nvPr/>
-      </p:nvGrpSpPr>
-      <p:grpSpPr/>
-      <p:sp>
-        <p:nvSpPr>
-          <p:cNvPr id="2" name="Rectangle 1"/>
-          <p:cNvSpPr/>
-          <p:nvPr/>
-        </p:nvSpPr>
-        <p:spPr>
-          <a:xfrm>
-            <a:off x="0" y="0"/>
             <a:ext cx="12191695" cy="164592"/>
           </a:xfrm>
           <a:prstGeom prst="rect">
@@ -5849,7 +5253,7 @@
         <p:spPr>
           <a:xfrm>
             <a:off x="457200" y="1591056"/>
-            <a:ext cx="3624986" cy="2331720"/>
+            <a:ext cx="5538063" cy="2331720"/>
           </a:xfrm>
           <a:prstGeom prst="roundRect">
             <a:avLst>
@@ -5894,7 +5298,7 @@
         <p:spPr>
           <a:xfrm>
             <a:off x="457200" y="1591056"/>
-            <a:ext cx="3624986" cy="64008"/>
+            <a:ext cx="5538063" cy="64008"/>
           </a:xfrm>
           <a:prstGeom prst="rect">
             <a:avLst/>
@@ -5937,7 +5341,7 @@
         <p:spPr>
           <a:xfrm>
             <a:off x="457200" y="1655064"/>
-            <a:ext cx="3624986" cy="27432"/>
+            <a:ext cx="5538063" cy="27432"/>
           </a:xfrm>
           <a:prstGeom prst="rect">
             <a:avLst/>
@@ -5987,7 +5391,7 @@
         </p:blipFill>
         <p:spPr>
           <a:xfrm>
-            <a:off x="1643329" y="1847087"/>
+            <a:off x="2599867" y="1847087"/>
             <a:ext cx="1252728" cy="1252728"/>
           </a:xfrm>
           <a:prstGeom prst="rect">
@@ -6004,7 +5408,7 @@
         <p:spPr>
           <a:xfrm>
             <a:off x="530352" y="3191256"/>
-            <a:ext cx="3478682" cy="621792"/>
+            <a:ext cx="5391759" cy="621792"/>
           </a:xfrm>
           <a:prstGeom prst="rect">
             <a:avLst/>
@@ -6052,8 +5456,8 @@
         </p:nvSpPr>
         <p:spPr>
           <a:xfrm>
-            <a:off x="4283354" y="1591056"/>
-            <a:ext cx="3624986" cy="2331720"/>
+            <a:off x="6196431" y="1591056"/>
+            <a:ext cx="5538063" cy="2331720"/>
           </a:xfrm>
           <a:prstGeom prst="roundRect">
             <a:avLst>
@@ -6097,8 +5501,8 @@
         </p:nvSpPr>
         <p:spPr>
           <a:xfrm>
-            <a:off x="4283354" y="1591056"/>
-            <a:ext cx="3624986" cy="64008"/>
+            <a:off x="6196431" y="1591056"/>
+            <a:ext cx="5538063" cy="64008"/>
           </a:xfrm>
           <a:prstGeom prst="rect">
             <a:avLst/>
@@ -6140,8 +5544,8 @@
         </p:nvSpPr>
         <p:spPr>
           <a:xfrm>
-            <a:off x="4283354" y="1655064"/>
-            <a:ext cx="3624986" cy="27432"/>
+            <a:off x="6196431" y="1655064"/>
+            <a:ext cx="5538063" cy="27432"/>
           </a:xfrm>
           <a:prstGeom prst="rect">
             <a:avLst/>
@@ -6177,7 +5581,7 @@
       </p:sp>
       <p:pic>
         <p:nvPicPr>
-          <p:cNvPr id="14" name="Picture 13" descr="mermaid.png"/>
+          <p:cNvPr id="14" name="Picture 13" descr="examlab.png"/>
           <p:cNvPicPr>
             <a:picLocks noChangeAspect="1"/>
           </p:cNvPicPr>
@@ -6191,7 +5595,7 @@
         </p:blipFill>
         <p:spPr>
           <a:xfrm>
-            <a:off x="5469483" y="1847087"/>
+            <a:off x="8339099" y="1847087"/>
             <a:ext cx="1252728" cy="1252728"/>
           </a:xfrm>
           <a:prstGeom prst="rect">
@@ -6207,8 +5611,8 @@
         </p:nvSpPr>
         <p:spPr>
           <a:xfrm>
-            <a:off x="4356506" y="3191256"/>
-            <a:ext cx="3478682" cy="621792"/>
+            <a:off x="6269583" y="3191256"/>
+            <a:ext cx="5391759" cy="621792"/>
           </a:xfrm>
           <a:prstGeom prst="rect">
             <a:avLst/>
@@ -6227,7 +5631,7 @@
                 </a:solidFill>
                 <a:latin typeface="Calibri"/>
               </a:rPr>
-              <a:t>Mermaid</a:t>
+              <a:t>ExamLab</a:t>
             </a:r>
           </a:p>
           <a:p>
@@ -6243,210 +5647,6 @@
                 </a:solidFill>
                 <a:latin typeface="Calibri"/>
               </a:rPr>
-              <a:t>Codigo del diagrama</a:t>
-            </a:r>
-          </a:p>
-        </p:txBody>
-      </p:sp>
-      <p:sp>
-        <p:nvSpPr>
-          <p:cNvPr id="16" name="Rounded Rectangle 15"/>
-          <p:cNvSpPr/>
-          <p:nvPr/>
-        </p:nvSpPr>
-        <p:spPr>
-          <a:xfrm>
-            <a:off x="8109508" y="1591056"/>
-            <a:ext cx="3624986" cy="2331720"/>
-          </a:xfrm>
-          <a:prstGeom prst="roundRect">
-            <a:avLst>
-              <a:gd name="adj" fmla="val 12000"/>
-            </a:avLst>
-          </a:prstGeom>
-          <a:solidFill>
-            <a:srgbClr val="F2F2F2"/>
-          </a:solidFill>
-          <a:ln>
-            <a:noFill/>
-          </a:ln>
-        </p:spPr>
-        <p:style>
-          <a:lnRef idx="1">
-            <a:schemeClr val="accent1"/>
-          </a:lnRef>
-          <a:fillRef idx="3">
-            <a:schemeClr val="accent1"/>
-          </a:fillRef>
-          <a:effectRef idx="2">
-            <a:schemeClr val="accent1"/>
-          </a:effectRef>
-          <a:fontRef idx="minor">
-            <a:schemeClr val="lt1"/>
-          </a:fontRef>
-        </p:style>
-        <p:txBody>
-          <a:bodyPr rtlCol="0" anchor="ctr"/>
-          <a:lstStyle/>
-          <a:p>
-            <a:pPr algn="ctr"/>
-          </a:p>
-        </p:txBody>
-      </p:sp>
-      <p:sp>
-        <p:nvSpPr>
-          <p:cNvPr id="17" name="Rectangle 16"/>
-          <p:cNvSpPr/>
-          <p:nvPr/>
-        </p:nvSpPr>
-        <p:spPr>
-          <a:xfrm>
-            <a:off x="8109508" y="1591056"/>
-            <a:ext cx="3624986" cy="64008"/>
-          </a:xfrm>
-          <a:prstGeom prst="rect">
-            <a:avLst/>
-          </a:prstGeom>
-          <a:solidFill>
-            <a:srgbClr val="095292"/>
-          </a:solidFill>
-          <a:ln>
-            <a:noFill/>
-          </a:ln>
-        </p:spPr>
-        <p:style>
-          <a:lnRef idx="1">
-            <a:schemeClr val="accent1"/>
-          </a:lnRef>
-          <a:fillRef idx="3">
-            <a:schemeClr val="accent1"/>
-          </a:fillRef>
-          <a:effectRef idx="2">
-            <a:schemeClr val="accent1"/>
-          </a:effectRef>
-          <a:fontRef idx="minor">
-            <a:schemeClr val="lt1"/>
-          </a:fontRef>
-        </p:style>
-        <p:txBody>
-          <a:bodyPr rtlCol="0" anchor="ctr"/>
-          <a:lstStyle/>
-          <a:p>
-            <a:pPr algn="ctr"/>
-          </a:p>
-        </p:txBody>
-      </p:sp>
-      <p:sp>
-        <p:nvSpPr>
-          <p:cNvPr id="18" name="Rectangle 17"/>
-          <p:cNvSpPr/>
-          <p:nvPr/>
-        </p:nvSpPr>
-        <p:spPr>
-          <a:xfrm>
-            <a:off x="8109508" y="1655064"/>
-            <a:ext cx="3624986" cy="27432"/>
-          </a:xfrm>
-          <a:prstGeom prst="rect">
-            <a:avLst/>
-          </a:prstGeom>
-          <a:solidFill>
-            <a:srgbClr val="FFD000"/>
-          </a:solidFill>
-          <a:ln>
-            <a:noFill/>
-          </a:ln>
-        </p:spPr>
-        <p:style>
-          <a:lnRef idx="1">
-            <a:schemeClr val="accent1"/>
-          </a:lnRef>
-          <a:fillRef idx="3">
-            <a:schemeClr val="accent1"/>
-          </a:fillRef>
-          <a:effectRef idx="2">
-            <a:schemeClr val="accent1"/>
-          </a:effectRef>
-          <a:fontRef idx="minor">
-            <a:schemeClr val="lt1"/>
-          </a:fontRef>
-        </p:style>
-        <p:txBody>
-          <a:bodyPr rtlCol="0" anchor="ctr"/>
-          <a:lstStyle/>
-          <a:p>
-            <a:pPr algn="ctr"/>
-          </a:p>
-        </p:txBody>
-      </p:sp>
-      <p:pic>
-        <p:nvPicPr>
-          <p:cNvPr id="19" name="Picture 18" descr="examlab.png"/>
-          <p:cNvPicPr>
-            <a:picLocks noChangeAspect="1"/>
-          </p:cNvPicPr>
-          <p:nvPr/>
-        </p:nvPicPr>
-        <p:blipFill>
-          <a:blip r:embed="rId4"/>
-          <a:stretch>
-            <a:fillRect/>
-          </a:stretch>
-        </p:blipFill>
-        <p:spPr>
-          <a:xfrm>
-            <a:off x="9295638" y="1847087"/>
-            <a:ext cx="1252728" cy="1252728"/>
-          </a:xfrm>
-          <a:prstGeom prst="rect">
-            <a:avLst/>
-          </a:prstGeom>
-        </p:spPr>
-      </p:pic>
-      <p:sp>
-        <p:nvSpPr>
-          <p:cNvPr id="20" name="TextBox 19"/>
-          <p:cNvSpPr txBox="1"/>
-          <p:nvPr/>
-        </p:nvSpPr>
-        <p:spPr>
-          <a:xfrm>
-            <a:off x="8182660" y="3191256"/>
-            <a:ext cx="3478682" cy="621792"/>
-          </a:xfrm>
-          <a:prstGeom prst="rect">
-            <a:avLst/>
-          </a:prstGeom>
-          <a:noFill/>
-        </p:spPr>
-        <p:txBody>
-          <a:bodyPr wrap="square" anchor="t"/>
-          <a:lstStyle/>
-          <a:p>
-            <a:pPr algn="ctr"/>
-            <a:r>
-              <a:rPr sz="1300" b="1" i="0">
-                <a:solidFill>
-                  <a:srgbClr val="095292"/>
-                </a:solidFill>
-                <a:latin typeface="Calibri"/>
-              </a:rPr>
-              <a:t>ExamLab</a:t>
-            </a:r>
-          </a:p>
-          <a:p>
-            <a:pPr algn="ctr">
-              <a:spcBef>
-                <a:spcPts val="200"/>
-              </a:spcBef>
-            </a:pPr>
-            <a:r>
-              <a:rPr sz="1000" b="0" i="0">
-                <a:solidFill>
-                  <a:srgbClr val="666666"/>
-                </a:solidFill>
-                <a:latin typeface="Calibri"/>
-              </a:rPr>
               <a:t>Donde se entrega</a:t>
             </a:r>
           </a:p>
@@ -6454,7 +5654,7 @@
       </p:sp>
       <p:sp>
         <p:nvSpPr>
-          <p:cNvPr id="21" name="TextBox 20"/>
+          <p:cNvPr id="16" name="TextBox 15"/>
           <p:cNvSpPr txBox="1"/>
           <p:nvPr/>
         </p:nvSpPr>
@@ -6522,7 +5722,7 @@
         <p:spPr>
           <a:xfrm>
             <a:off x="0" y="0"/>
-            <a:ext cx="12191695" cy="1170432"/>
+            <a:ext cx="12191695" cy="960120"/>
           </a:xfrm>
           <a:prstGeom prst="rect">
             <a:avLst/>
@@ -6564,7 +5764,7 @@
         </p:nvSpPr>
         <p:spPr>
           <a:xfrm>
-            <a:off x="0" y="1170432"/>
+            <a:off x="0" y="960120"/>
             <a:ext cx="12191695" cy="41148"/>
           </a:xfrm>
           <a:prstGeom prst="rect">
@@ -6608,7 +5808,7 @@
         <p:spPr>
           <a:xfrm>
             <a:off x="457200" y="164592"/>
-            <a:ext cx="11277295" cy="384048"/>
+            <a:ext cx="11277295" cy="502920"/>
           </a:xfrm>
           <a:prstGeom prst="rect">
             <a:avLst/>
@@ -6628,7 +5828,7 @@
                 </a:solidFill>
                 <a:latin typeface="Calibri"/>
               </a:rPr>
-              <a:t>Del boceto a ExamLab (diagrama)</a:t>
+              <a:t>Taller PI (paso a paso)</a:t>
             </a:r>
           </a:p>
         </p:txBody>
@@ -6641,8 +5841,8 @@
         </p:nvSpPr>
         <p:spPr>
           <a:xfrm>
-            <a:off x="457200" y="566928"/>
-            <a:ext cx="11277295" cy="411480"/>
+            <a:off x="457200" y="1170432"/>
+            <a:ext cx="11277295" cy="5230368"/>
           </a:xfrm>
           <a:prstGeom prst="rect">
             <a:avLst/>
@@ -6655,705 +5855,137 @@
           </a:bodyPr>
           <a:lstStyle/>
           <a:p>
-            <a:r>
-              <a:rPr sz="1400" b="0" i="0">
-                <a:solidFill>
-                  <a:srgbClr val="B8D8EE"/>
-                </a:solidFill>
-                <a:latin typeface="Calibri"/>
-              </a:rPr>
-              <a:t>El diagrama se entrega como código Mermaid dentro de ExamLab, no como imagen</a:t>
-            </a:r>
-          </a:p>
-        </p:txBody>
-      </p:sp>
-      <p:sp>
-        <p:nvSpPr>
-          <p:cNvPr id="6" name="Rounded Rectangle 5"/>
-          <p:cNvSpPr/>
-          <p:nvPr/>
-        </p:nvSpPr>
-        <p:spPr>
-          <a:xfrm>
-            <a:off x="457200" y="1659636"/>
-            <a:ext cx="11277295" cy="1051560"/>
-          </a:xfrm>
-          <a:prstGeom prst="roundRect">
-            <a:avLst>
-              <a:gd name="adj" fmla="val 12000"/>
-            </a:avLst>
-          </a:prstGeom>
-          <a:solidFill>
-            <a:srgbClr val="F2F2F2"/>
-          </a:solidFill>
-          <a:ln>
-            <a:noFill/>
-          </a:ln>
-        </p:spPr>
-        <p:style>
-          <a:lnRef idx="1">
-            <a:schemeClr val="accent1"/>
-          </a:lnRef>
-          <a:fillRef idx="3">
-            <a:schemeClr val="accent1"/>
-          </a:fillRef>
-          <a:effectRef idx="2">
-            <a:schemeClr val="accent1"/>
-          </a:effectRef>
-          <a:fontRef idx="minor">
-            <a:schemeClr val="lt1"/>
-          </a:fontRef>
-        </p:style>
-        <p:txBody>
-          <a:bodyPr rtlCol="0" anchor="ctr"/>
-          <a:lstStyle/>
-          <a:p>
-            <a:pPr algn="ctr"/>
-          </a:p>
-        </p:txBody>
-      </p:sp>
-      <p:sp>
-        <p:nvSpPr>
-          <p:cNvPr id="7" name="Rounded Rectangle 6"/>
-          <p:cNvSpPr/>
-          <p:nvPr/>
-        </p:nvSpPr>
-        <p:spPr>
-          <a:xfrm>
-            <a:off x="594360" y="1965960"/>
-            <a:ext cx="438912" cy="438912"/>
-          </a:xfrm>
-          <a:prstGeom prst="roundRect">
-            <a:avLst>
-              <a:gd name="adj" fmla="val 12000"/>
-            </a:avLst>
-          </a:prstGeom>
-          <a:solidFill>
-            <a:srgbClr val="095292"/>
-          </a:solidFill>
-          <a:ln>
-            <a:noFill/>
-          </a:ln>
-        </p:spPr>
-        <p:style>
-          <a:lnRef idx="1">
-            <a:schemeClr val="accent1"/>
-          </a:lnRef>
-          <a:fillRef idx="3">
-            <a:schemeClr val="accent1"/>
-          </a:fillRef>
-          <a:effectRef idx="2">
-            <a:schemeClr val="accent1"/>
-          </a:effectRef>
-          <a:fontRef idx="minor">
-            <a:schemeClr val="lt1"/>
-          </a:fontRef>
-        </p:style>
-        <p:txBody>
-          <a:bodyPr rtlCol="0" anchor="ctr"/>
-          <a:lstStyle/>
-          <a:p>
-            <a:pPr algn="ctr"/>
-          </a:p>
-        </p:txBody>
-      </p:sp>
-      <p:sp>
-        <p:nvSpPr>
-          <p:cNvPr id="8" name="TextBox 7"/>
-          <p:cNvSpPr txBox="1"/>
-          <p:nvPr/>
-        </p:nvSpPr>
-        <p:spPr>
-          <a:xfrm>
-            <a:off x="594360" y="1965960"/>
-            <a:ext cx="438912" cy="438912"/>
-          </a:xfrm>
-          <a:prstGeom prst="rect">
-            <a:avLst/>
-          </a:prstGeom>
-          <a:noFill/>
-        </p:spPr>
-        <p:txBody>
-          <a:bodyPr wrap="square" anchor="ctr"/>
-          <a:lstStyle/>
-          <a:p>
-            <a:pPr algn="ctr"/>
+            <a:pPr>
+              <a:spcAft>
+                <a:spcPts val="800"/>
+              </a:spcAft>
+            </a:pPr>
             <a:r>
               <a:rPr sz="1600" b="1" i="0">
                 <a:solidFill>
-                  <a:srgbClr val="FFFFFF"/>
-                </a:solidFill>
-                <a:latin typeface="Calibri"/>
-              </a:rPr>
-              <a:t>1</a:t>
-            </a:r>
-          </a:p>
-        </p:txBody>
-      </p:sp>
-      <p:sp>
-        <p:nvSpPr>
-          <p:cNvPr id="9" name="TextBox 8"/>
-          <p:cNvSpPr txBox="1"/>
-          <p:nvPr/>
-        </p:nvSpPr>
-        <p:spPr>
-          <a:xfrm>
-            <a:off x="1188720" y="1751076"/>
-            <a:ext cx="10271455" cy="886968"/>
-          </a:xfrm>
-          <a:prstGeom prst="rect">
-            <a:avLst/>
-          </a:prstGeom>
-          <a:noFill/>
-        </p:spPr>
-        <p:txBody>
-          <a:bodyPr wrap="square" anchor="ctr"/>
-          <a:lstStyle/>
-          <a:p>
-            <a:r>
-              <a:rPr sz="1500" b="1" i="0">
-                <a:solidFill>
-                  <a:srgbClr val="095292"/>
-                </a:solidFill>
-                <a:latin typeface="Calibri"/>
-              </a:rPr>
-              <a:t>Disena visual</a:t>
+                  <a:srgbClr val="333333"/>
+                </a:solidFill>
+                <a:latin typeface="Calibri"/>
+              </a:rPr>
+              <a:t>1.</a:t>
+            </a:r>
+            <a:r>
+              <a:rPr sz="1600" b="0" i="0">
+                <a:solidFill>
+                  <a:srgbClr val="333333"/>
+                </a:solidFill>
+                <a:latin typeface="Calibri"/>
+              </a:rPr>
+              <a:t> Paso 1: construya en la pregunta 11 la tabla de costos con una fila por cada componente de su despliegue y las columnas componente, driver, nivel B/M/A y apalancamiento; verifique que cada driver sea una variable contable (horas encendidas, GB de salida, GB almacenados, minutos de CI) y no «el uso».</a:t>
             </a:r>
           </a:p>
           <a:p>
             <a:pPr>
-              <a:spcBef>
-                <a:spcPts val="200"/>
-              </a:spcBef>
+              <a:spcAft>
+                <a:spcPts val="800"/>
+              </a:spcAft>
             </a:pPr>
             <a:r>
-              <a:rPr sz="1300" b="0" i="0">
+              <a:rPr sz="1600" b="0" i="0">
                 <a:solidFill>
                   <a:srgbClr val="333333"/>
                 </a:solidFill>
                 <a:latin typeface="Calibri"/>
               </a:rPr>
-              <a:t>Dibuja el diagrama como quieras en Excalidraw o draw.io: es mas rapido arrastrar cajas que escribir codigo, y ahi es donde piensas el modelo.</a:t>
-            </a:r>
-          </a:p>
-        </p:txBody>
-      </p:sp>
-      <p:sp>
-        <p:nvSpPr>
-          <p:cNvPr id="10" name="Rounded Rectangle 9"/>
-          <p:cNvSpPr/>
-          <p:nvPr/>
-        </p:nvSpPr>
-        <p:spPr>
-          <a:xfrm>
-            <a:off x="457200" y="2802636"/>
-            <a:ext cx="11277295" cy="1051560"/>
-          </a:xfrm>
-          <a:prstGeom prst="roundRect">
-            <a:avLst>
-              <a:gd name="adj" fmla="val 12000"/>
-            </a:avLst>
-          </a:prstGeom>
-          <a:solidFill>
-            <a:srgbClr val="E8F4FA"/>
-          </a:solidFill>
-          <a:ln>
-            <a:noFill/>
-          </a:ln>
-        </p:spPr>
-        <p:style>
-          <a:lnRef idx="1">
-            <a:schemeClr val="accent1"/>
-          </a:lnRef>
-          <a:fillRef idx="3">
-            <a:schemeClr val="accent1"/>
-          </a:fillRef>
-          <a:effectRef idx="2">
-            <a:schemeClr val="accent1"/>
-          </a:effectRef>
-          <a:fontRef idx="minor">
-            <a:schemeClr val="lt1"/>
-          </a:fontRef>
-        </p:style>
-        <p:txBody>
-          <a:bodyPr rtlCol="0" anchor="ctr"/>
-          <a:lstStyle/>
-          <a:p>
-            <a:pPr algn="ctr"/>
-          </a:p>
-        </p:txBody>
-      </p:sp>
-      <p:sp>
-        <p:nvSpPr>
-          <p:cNvPr id="11" name="Rounded Rectangle 10"/>
-          <p:cNvSpPr/>
-          <p:nvPr/>
-        </p:nvSpPr>
-        <p:spPr>
-          <a:xfrm>
-            <a:off x="594360" y="3108960"/>
-            <a:ext cx="438912" cy="438912"/>
-          </a:xfrm>
-          <a:prstGeom prst="roundRect">
-            <a:avLst>
-              <a:gd name="adj" fmla="val 12000"/>
-            </a:avLst>
-          </a:prstGeom>
-          <a:solidFill>
-            <a:srgbClr val="095292"/>
-          </a:solidFill>
-          <a:ln>
-            <a:noFill/>
-          </a:ln>
-        </p:spPr>
-        <p:style>
-          <a:lnRef idx="1">
-            <a:schemeClr val="accent1"/>
-          </a:lnRef>
-          <a:fillRef idx="3">
-            <a:schemeClr val="accent1"/>
-          </a:fillRef>
-          <a:effectRef idx="2">
-            <a:schemeClr val="accent1"/>
-          </a:effectRef>
-          <a:fontRef idx="minor">
-            <a:schemeClr val="lt1"/>
-          </a:fontRef>
-        </p:style>
-        <p:txBody>
-          <a:bodyPr rtlCol="0" anchor="ctr"/>
-          <a:lstStyle/>
-          <a:p>
-            <a:pPr algn="ctr"/>
-          </a:p>
-        </p:txBody>
-      </p:sp>
-      <p:sp>
-        <p:nvSpPr>
-          <p:cNvPr id="12" name="TextBox 11"/>
-          <p:cNvSpPr txBox="1"/>
-          <p:nvPr/>
-        </p:nvSpPr>
-        <p:spPr>
-          <a:xfrm>
-            <a:off x="594360" y="3108960"/>
-            <a:ext cx="438912" cy="438912"/>
-          </a:xfrm>
-          <a:prstGeom prst="rect">
-            <a:avLst/>
-          </a:prstGeom>
-          <a:noFill/>
-        </p:spPr>
-        <p:txBody>
-          <a:bodyPr wrap="square" anchor="ctr"/>
-          <a:lstStyle/>
-          <a:p>
-            <a:pPr algn="ctr"/>
+              <a:t>–   </a:t>
+            </a:r>
             <a:r>
               <a:rPr sz="1600" b="1" i="0">
                 <a:solidFill>
-                  <a:srgbClr val="FFFFFF"/>
-                </a:solidFill>
-                <a:latin typeface="Calibri"/>
-              </a:rPr>
-              <a:t>2</a:t>
-            </a:r>
-          </a:p>
-        </p:txBody>
-      </p:sp>
-      <p:sp>
-        <p:nvSpPr>
-          <p:cNvPr id="13" name="TextBox 12"/>
-          <p:cNvSpPr txBox="1"/>
-          <p:nvPr/>
-        </p:nvSpPr>
-        <p:spPr>
-          <a:xfrm>
-            <a:off x="1188720" y="2894076"/>
-            <a:ext cx="10271455" cy="886968"/>
-          </a:xfrm>
-          <a:prstGeom prst="rect">
-            <a:avLst/>
-          </a:prstGeom>
-          <a:noFill/>
-        </p:spPr>
-        <p:txBody>
-          <a:bodyPr wrap="square" anchor="ctr"/>
-          <a:lstStyle/>
-          <a:p>
-            <a:r>
-              <a:rPr sz="1500" b="1" i="0">
-                <a:solidFill>
-                  <a:srgbClr val="095292"/>
-                </a:solidFill>
-                <a:latin typeface="Calibri"/>
-              </a:rPr>
-              <a:t>Traduce con IA</a:t>
+                  <a:srgbClr val="333333"/>
+                </a:solidFill>
+                <a:latin typeface="Calibri"/>
+              </a:rPr>
+              <a:t>2.</a:t>
+            </a:r>
+            <a:r>
+              <a:rPr sz="1600" b="0" i="0">
+                <a:solidFill>
+                  <a:srgbClr val="333333"/>
+                </a:solidFill>
+                <a:latin typeface="Calibri"/>
+              </a:rPr>
+              <a:t> Paso 2: fuerce al menos un Alto y un Bajo con su justificacion. Marcar todo como Medio para no decidir es lo que la pregunta busca descartar, y ese criterio vale cero si todas las filas quedan iguales.</a:t>
             </a:r>
           </a:p>
           <a:p>
             <a:pPr>
-              <a:spcBef>
-                <a:spcPts val="200"/>
-              </a:spcBef>
+              <a:spcAft>
+                <a:spcPts val="800"/>
+              </a:spcAft>
             </a:pPr>
             <a:r>
-              <a:rPr sz="1300" b="0" i="0">
+              <a:rPr sz="1600" b="0" i="0">
                 <a:solidFill>
                   <a:srgbClr val="333333"/>
                 </a:solidFill>
                 <a:latin typeface="Calibri"/>
               </a:rPr>
-              <a:t>Copia o describe tu boceto a una IA y pidele el codigo Mermaid: «convierte este diagrama a Mermaid usando mindmap». Revisa el resultado: la IA acierta la sintaxis, no tu modelo.</a:t>
-            </a:r>
-          </a:p>
-        </p:txBody>
-      </p:sp>
-      <p:sp>
-        <p:nvSpPr>
-          <p:cNvPr id="14" name="Rounded Rectangle 13"/>
-          <p:cNvSpPr/>
-          <p:nvPr/>
-        </p:nvSpPr>
-        <p:spPr>
-          <a:xfrm>
-            <a:off x="457200" y="3945636"/>
-            <a:ext cx="11277295" cy="1051560"/>
-          </a:xfrm>
-          <a:prstGeom prst="roundRect">
-            <a:avLst>
-              <a:gd name="adj" fmla="val 12000"/>
-            </a:avLst>
-          </a:prstGeom>
-          <a:solidFill>
-            <a:srgbClr val="F2F2F2"/>
-          </a:solidFill>
-          <a:ln>
-            <a:noFill/>
-          </a:ln>
-        </p:spPr>
-        <p:style>
-          <a:lnRef idx="1">
-            <a:schemeClr val="accent1"/>
-          </a:lnRef>
-          <a:fillRef idx="3">
-            <a:schemeClr val="accent1"/>
-          </a:fillRef>
-          <a:effectRef idx="2">
-            <a:schemeClr val="accent1"/>
-          </a:effectRef>
-          <a:fontRef idx="minor">
-            <a:schemeClr val="lt1"/>
-          </a:fontRef>
-        </p:style>
-        <p:txBody>
-          <a:bodyPr rtlCol="0" anchor="ctr"/>
-          <a:lstStyle/>
-          <a:p>
-            <a:pPr algn="ctr"/>
-          </a:p>
-        </p:txBody>
-      </p:sp>
-      <p:sp>
-        <p:nvSpPr>
-          <p:cNvPr id="15" name="Rounded Rectangle 14"/>
-          <p:cNvSpPr/>
-          <p:nvPr/>
-        </p:nvSpPr>
-        <p:spPr>
-          <a:xfrm>
-            <a:off x="594360" y="4251960"/>
-            <a:ext cx="438912" cy="438912"/>
-          </a:xfrm>
-          <a:prstGeom prst="roundRect">
-            <a:avLst>
-              <a:gd name="adj" fmla="val 12000"/>
-            </a:avLst>
-          </a:prstGeom>
-          <a:solidFill>
-            <a:srgbClr val="095292"/>
-          </a:solidFill>
-          <a:ln>
-            <a:noFill/>
-          </a:ln>
-        </p:spPr>
-        <p:style>
-          <a:lnRef idx="1">
-            <a:schemeClr val="accent1"/>
-          </a:lnRef>
-          <a:fillRef idx="3">
-            <a:schemeClr val="accent1"/>
-          </a:fillRef>
-          <a:effectRef idx="2">
-            <a:schemeClr val="accent1"/>
-          </a:effectRef>
-          <a:fontRef idx="minor">
-            <a:schemeClr val="lt1"/>
-          </a:fontRef>
-        </p:style>
-        <p:txBody>
-          <a:bodyPr rtlCol="0" anchor="ctr"/>
-          <a:lstStyle/>
-          <a:p>
-            <a:pPr algn="ctr"/>
-          </a:p>
-        </p:txBody>
-      </p:sp>
-      <p:sp>
-        <p:nvSpPr>
-          <p:cNvPr id="16" name="TextBox 15"/>
-          <p:cNvSpPr txBox="1"/>
-          <p:nvPr/>
-        </p:nvSpPr>
-        <p:spPr>
-          <a:xfrm>
-            <a:off x="594360" y="4251960"/>
-            <a:ext cx="438912" cy="438912"/>
-          </a:xfrm>
-          <a:prstGeom prst="rect">
-            <a:avLst/>
-          </a:prstGeom>
-          <a:noFill/>
-        </p:spPr>
-        <p:txBody>
-          <a:bodyPr wrap="square" anchor="ctr"/>
-          <a:lstStyle/>
-          <a:p>
-            <a:pPr algn="ctr"/>
+              <a:t>–   </a:t>
+            </a:r>
             <a:r>
               <a:rPr sz="1600" b="1" i="0">
                 <a:solidFill>
-                  <a:srgbClr val="FFFFFF"/>
-                </a:solidFill>
-                <a:latin typeface="Calibri"/>
-              </a:rPr>
-              <a:t>3</a:t>
-            </a:r>
-          </a:p>
-        </p:txBody>
-      </p:sp>
-      <p:sp>
-        <p:nvSpPr>
-          <p:cNvPr id="17" name="TextBox 16"/>
-          <p:cNvSpPr txBox="1"/>
-          <p:nvPr/>
-        </p:nvSpPr>
-        <p:spPr>
-          <a:xfrm>
-            <a:off x="1188720" y="4037076"/>
-            <a:ext cx="10271455" cy="886968"/>
-          </a:xfrm>
-          <a:prstGeom prst="rect">
-            <a:avLst/>
-          </a:prstGeom>
-          <a:noFill/>
-        </p:spPr>
-        <p:txBody>
-          <a:bodyPr wrap="square" anchor="ctr"/>
-          <a:lstStyle/>
-          <a:p>
-            <a:r>
-              <a:rPr sz="1500" b="1" i="0">
-                <a:solidFill>
-                  <a:srgbClr val="095292"/>
-                </a:solidFill>
-                <a:latin typeface="Calibri"/>
-              </a:rPr>
-              <a:t>Pega y renderiza en ExamLab</a:t>
+                  <a:srgbClr val="333333"/>
+                </a:solidFill>
+                <a:latin typeface="Calibri"/>
+              </a:rPr>
+              <a:t>3.</a:t>
+            </a:r>
+            <a:r>
+              <a:rPr sz="1600" b="0" i="0">
+                <a:solidFill>
+                  <a:srgbClr val="333333"/>
+                </a:solidFill>
+                <a:latin typeface="Calibri"/>
+              </a:rPr>
+              <a:t> Paso 3: escriba en la pregunta 12 tres acciones de sostenibilidad, cada una con el artefacto donde se comprueba y como se comprueba; aplique la prueba de que otra persona pueda decir en seis meses, mirando el repositorio, si la accion se aplico.</a:t>
             </a:r>
           </a:p>
           <a:p>
             <a:pPr>
-              <a:spcBef>
-                <a:spcPts val="200"/>
-              </a:spcBef>
+              <a:spcAft>
+                <a:spcPts val="800"/>
+              </a:spcAft>
             </a:pPr>
             <a:r>
-              <a:rPr sz="1300" b="0" i="0">
+              <a:rPr sz="1600" b="0" i="0">
                 <a:solidFill>
                   <a:srgbClr val="333333"/>
                 </a:solidFill>
                 <a:latin typeface="Calibri"/>
               </a:rPr>
-              <a:t>Pega ese codigo en la caja de texto de la pregunta y mira como lo dibuja la plataforma. Si no renderiza, corrige ahi mismo: lo que se califica es el diagrama renderizado dentro de ExamLab.</a:t>
-            </a:r>
-          </a:p>
-        </p:txBody>
-      </p:sp>
-      <p:sp>
-        <p:nvSpPr>
-          <p:cNvPr id="18" name="Rounded Rectangle 17"/>
-          <p:cNvSpPr/>
-          <p:nvPr/>
-        </p:nvSpPr>
-        <p:spPr>
-          <a:xfrm>
-            <a:off x="457200" y="5088636"/>
-            <a:ext cx="11277295" cy="1051560"/>
-          </a:xfrm>
-          <a:prstGeom prst="roundRect">
-            <a:avLst>
-              <a:gd name="adj" fmla="val 12000"/>
-            </a:avLst>
-          </a:prstGeom>
-          <a:solidFill>
-            <a:srgbClr val="E8F4FA"/>
-          </a:solidFill>
-          <a:ln>
-            <a:noFill/>
-          </a:ln>
-        </p:spPr>
-        <p:style>
-          <a:lnRef idx="1">
-            <a:schemeClr val="accent1"/>
-          </a:lnRef>
-          <a:fillRef idx="3">
-            <a:schemeClr val="accent1"/>
-          </a:fillRef>
-          <a:effectRef idx="2">
-            <a:schemeClr val="accent1"/>
-          </a:effectRef>
-          <a:fontRef idx="minor">
-            <a:schemeClr val="lt1"/>
-          </a:fontRef>
-        </p:style>
-        <p:txBody>
-          <a:bodyPr rtlCol="0" anchor="ctr"/>
-          <a:lstStyle/>
-          <a:p>
-            <a:pPr algn="ctr"/>
-          </a:p>
-        </p:txBody>
-      </p:sp>
-      <p:sp>
-        <p:nvSpPr>
-          <p:cNvPr id="19" name="Rounded Rectangle 18"/>
-          <p:cNvSpPr/>
-          <p:nvPr/>
-        </p:nvSpPr>
-        <p:spPr>
-          <a:xfrm>
-            <a:off x="594360" y="5394960"/>
-            <a:ext cx="438912" cy="438912"/>
-          </a:xfrm>
-          <a:prstGeom prst="roundRect">
-            <a:avLst>
-              <a:gd name="adj" fmla="val 12000"/>
-            </a:avLst>
-          </a:prstGeom>
-          <a:solidFill>
-            <a:srgbClr val="095292"/>
-          </a:solidFill>
-          <a:ln>
-            <a:noFill/>
-          </a:ln>
-        </p:spPr>
-        <p:style>
-          <a:lnRef idx="1">
-            <a:schemeClr val="accent1"/>
-          </a:lnRef>
-          <a:fillRef idx="3">
-            <a:schemeClr val="accent1"/>
-          </a:fillRef>
-          <a:effectRef idx="2">
-            <a:schemeClr val="accent1"/>
-          </a:effectRef>
-          <a:fontRef idx="minor">
-            <a:schemeClr val="lt1"/>
-          </a:fontRef>
-        </p:style>
-        <p:txBody>
-          <a:bodyPr rtlCol="0" anchor="ctr"/>
-          <a:lstStyle/>
-          <a:p>
-            <a:pPr algn="ctr"/>
-          </a:p>
-        </p:txBody>
-      </p:sp>
-      <p:sp>
-        <p:nvSpPr>
-          <p:cNvPr id="20" name="TextBox 19"/>
-          <p:cNvSpPr txBox="1"/>
-          <p:nvPr/>
-        </p:nvSpPr>
-        <p:spPr>
-          <a:xfrm>
-            <a:off x="594360" y="5394960"/>
-            <a:ext cx="438912" cy="438912"/>
-          </a:xfrm>
-          <a:prstGeom prst="rect">
-            <a:avLst/>
-          </a:prstGeom>
-          <a:noFill/>
-        </p:spPr>
-        <p:txBody>
-          <a:bodyPr wrap="square" anchor="ctr"/>
-          <a:lstStyle/>
-          <a:p>
-            <a:pPr algn="ctr"/>
+              <a:t>–   </a:t>
+            </a:r>
             <a:r>
               <a:rPr sz="1600" b="1" i="0">
                 <a:solidFill>
-                  <a:srgbClr val="FFFFFF"/>
-                </a:solidFill>
-                <a:latin typeface="Calibri"/>
-              </a:rPr>
-              <a:t>4</a:t>
-            </a:r>
-          </a:p>
-        </p:txBody>
-      </p:sp>
-      <p:sp>
-        <p:nvSpPr>
-          <p:cNvPr id="21" name="TextBox 20"/>
-          <p:cNvSpPr txBox="1"/>
-          <p:nvPr/>
-        </p:nvSpPr>
-        <p:spPr>
-          <a:xfrm>
-            <a:off x="1188720" y="5180076"/>
-            <a:ext cx="10271455" cy="886968"/>
-          </a:xfrm>
-          <a:prstGeom prst="rect">
-            <a:avLst/>
-          </a:prstGeom>
-          <a:noFill/>
-        </p:spPr>
-        <p:txBody>
-          <a:bodyPr wrap="square" anchor="ctr"/>
-          <a:lstStyle/>
-          <a:p>
-            <a:r>
-              <a:rPr sz="1500" b="1" i="0">
-                <a:solidFill>
-                  <a:srgbClr val="095292"/>
-                </a:solidFill>
-                <a:latin typeface="Calibri"/>
-              </a:rPr>
-              <a:t>Guarda el PNG para tu PI</a:t>
-            </a:r>
-          </a:p>
-          <a:p>
-            <a:pPr>
-              <a:spcBef>
-                <a:spcPts val="200"/>
-              </a:spcBef>
-            </a:pPr>
-            <a:r>
-              <a:rPr sz="1300" b="0" i="0">
-                <a:solidFill>
                   <a:srgbClr val="333333"/>
                 </a:solidFill>
                 <a:latin typeface="Calibri"/>
               </a:rPr>
-              <a:t>Exporta tambien la imagen a la carpeta de tu Proyecto Integrador. Esa copia es para tu informe; no reemplaza la respuesta en la plataforma.</a:t>
-            </a:r>
-          </a:p>
-        </p:txBody>
-      </p:sp>
-      <p:sp>
-        <p:nvSpPr>
-          <p:cNvPr id="22" name="TextBox 21"/>
+              <a:t>4.</a:t>
+            </a:r>
+            <a:r>
+              <a:rPr sz="1600" b="0" i="0">
+                <a:solidFill>
+                  <a:srgbClr val="333333"/>
+                </a:solidFill>
+                <a:latin typeface="Calibri"/>
+              </a:rPr>
+              <a:t> Paso 4: ate al menos una de las tres acciones a un driver de costo de la pregunta 11 y suba la actividad completa del Corte 2 a ExamLab antes del domingo 23:59. Es una clase autonoma: no hay encuentro sincrono, y las dudas van por el foro.</a:t>
+            </a:r>
+          </a:p>
+        </p:txBody>
+      </p:sp>
+      <p:sp>
+        <p:nvSpPr>
+          <p:cNvPr id="6" name="TextBox 5"/>
           <p:cNvSpPr txBox="1"/>
           <p:nvPr/>
         </p:nvSpPr>
@@ -7527,21 +6159,109 @@
                 </a:solidFill>
                 <a:latin typeface="Calibri"/>
               </a:rPr>
-              <a:t>Taller PI (paso a paso)</a:t>
-            </a:r>
-          </a:p>
-        </p:txBody>
-      </p:sp>
-      <p:sp>
-        <p:nvSpPr>
-          <p:cNvPr id="5" name="TextBox 4"/>
+              <a:t>Para continuar (PI)</a:t>
+            </a:r>
+          </a:p>
+        </p:txBody>
+      </p:sp>
+      <p:sp>
+        <p:nvSpPr>
+          <p:cNvPr id="5" name="Rounded Rectangle 4"/>
+          <p:cNvSpPr/>
+          <p:nvPr/>
+        </p:nvSpPr>
+        <p:spPr>
+          <a:xfrm>
+            <a:off x="457200" y="1261872"/>
+            <a:ext cx="11277295" cy="1051560"/>
+          </a:xfrm>
+          <a:prstGeom prst="roundRect">
+            <a:avLst>
+              <a:gd name="adj" fmla="val 12000"/>
+            </a:avLst>
+          </a:prstGeom>
+          <a:solidFill>
+            <a:srgbClr val="E8F4FA"/>
+          </a:solidFill>
+          <a:ln>
+            <a:noFill/>
+          </a:ln>
+        </p:spPr>
+        <p:style>
+          <a:lnRef idx="1">
+            <a:schemeClr val="accent1"/>
+          </a:lnRef>
+          <a:fillRef idx="3">
+            <a:schemeClr val="accent1"/>
+          </a:fillRef>
+          <a:effectRef idx="2">
+            <a:schemeClr val="accent1"/>
+          </a:effectRef>
+          <a:fontRef idx="minor">
+            <a:schemeClr val="lt1"/>
+          </a:fontRef>
+        </p:style>
+        <p:txBody>
+          <a:bodyPr rtlCol="0" anchor="ctr"/>
+          <a:lstStyle/>
+          <a:p>
+            <a:pPr algn="ctr"/>
+          </a:p>
+        </p:txBody>
+      </p:sp>
+      <p:sp>
+        <p:nvSpPr>
+          <p:cNvPr id="6" name="Rectangle 5"/>
+          <p:cNvSpPr/>
+          <p:nvPr/>
+        </p:nvSpPr>
+        <p:spPr>
+          <a:xfrm>
+            <a:off x="457200" y="1261872"/>
+            <a:ext cx="128016" cy="1051560"/>
+          </a:xfrm>
+          <a:prstGeom prst="rect">
+            <a:avLst/>
+          </a:prstGeom>
+          <a:solidFill>
+            <a:srgbClr val="269CCB"/>
+          </a:solidFill>
+          <a:ln>
+            <a:noFill/>
+          </a:ln>
+        </p:spPr>
+        <p:style>
+          <a:lnRef idx="1">
+            <a:schemeClr val="accent1"/>
+          </a:lnRef>
+          <a:fillRef idx="3">
+            <a:schemeClr val="accent1"/>
+          </a:fillRef>
+          <a:effectRef idx="2">
+            <a:schemeClr val="accent1"/>
+          </a:effectRef>
+          <a:fontRef idx="minor">
+            <a:schemeClr val="lt1"/>
+          </a:fontRef>
+        </p:style>
+        <p:txBody>
+          <a:bodyPr rtlCol="0" anchor="ctr"/>
+          <a:lstStyle/>
+          <a:p>
+            <a:pPr algn="ctr"/>
+          </a:p>
+        </p:txBody>
+      </p:sp>
+      <p:sp>
+        <p:nvSpPr>
+          <p:cNvPr id="7" name="TextBox 6"/>
           <p:cNvSpPr txBox="1"/>
           <p:nvPr/>
         </p:nvSpPr>
         <p:spPr>
           <a:xfrm>
-            <a:off x="457200" y="1170432"/>
-            <a:ext cx="11277295" cy="5230368"/>
+            <a:off x="777240" y="1399031"/>
+            <a:ext cx="10774375" cy="822959"/>
           </a:xfrm>
           <a:prstGeom prst="rect">
             <a:avLst/>
@@ -7554,171 +6274,313 @@
           </a:bodyPr>
           <a:lstStyle/>
           <a:p>
+            <a:r>
+              <a:rPr sz="1200" b="1" i="0">
+                <a:solidFill>
+                  <a:srgbClr val="269CCB"/>
+                </a:solidFill>
+                <a:latin typeface="Calibri"/>
+              </a:rPr>
+              <a:t>Info</a:t>
+            </a:r>
+          </a:p>
+          <a:p>
             <a:pPr>
-              <a:spcAft>
-                <a:spcPts val="800"/>
-              </a:spcAft>
+              <a:spcBef>
+                <a:spcPts val="400"/>
+              </a:spcBef>
             </a:pPr>
             <a:r>
-              <a:rPr sz="1600" b="1" i="0">
+              <a:rPr sz="1400" b="0" i="0">
                 <a:solidFill>
                   <a:srgbClr val="333333"/>
                 </a:solidFill>
                 <a:latin typeface="Calibri"/>
               </a:rPr>
-              <a:t>1.</a:t>
-            </a:r>
-            <a:r>
-              <a:rPr sz="1600" b="0" i="0">
+              <a:t>Entregable: Sección Costos/Sostenibilidad del informe (bajo/medio + drivers)</a:t>
+            </a:r>
+          </a:p>
+        </p:txBody>
+      </p:sp>
+      <p:sp>
+        <p:nvSpPr>
+          <p:cNvPr id="8" name="Rounded Rectangle 7"/>
+          <p:cNvSpPr/>
+          <p:nvPr/>
+        </p:nvSpPr>
+        <p:spPr>
+          <a:xfrm>
+            <a:off x="457200" y="2478024"/>
+            <a:ext cx="11277295" cy="1051560"/>
+          </a:xfrm>
+          <a:prstGeom prst="roundRect">
+            <a:avLst>
+              <a:gd name="adj" fmla="val 12000"/>
+            </a:avLst>
+          </a:prstGeom>
+          <a:solidFill>
+            <a:srgbClr val="FFF8E1"/>
+          </a:solidFill>
+          <a:ln>
+            <a:noFill/>
+          </a:ln>
+        </p:spPr>
+        <p:style>
+          <a:lnRef idx="1">
+            <a:schemeClr val="accent1"/>
+          </a:lnRef>
+          <a:fillRef idx="3">
+            <a:schemeClr val="accent1"/>
+          </a:fillRef>
+          <a:effectRef idx="2">
+            <a:schemeClr val="accent1"/>
+          </a:effectRef>
+          <a:fontRef idx="minor">
+            <a:schemeClr val="lt1"/>
+          </a:fontRef>
+        </p:style>
+        <p:txBody>
+          <a:bodyPr rtlCol="0" anchor="ctr"/>
+          <a:lstStyle/>
+          <a:p>
+            <a:pPr algn="ctr"/>
+          </a:p>
+        </p:txBody>
+      </p:sp>
+      <p:sp>
+        <p:nvSpPr>
+          <p:cNvPr id="9" name="Rectangle 8"/>
+          <p:cNvSpPr/>
+          <p:nvPr/>
+        </p:nvSpPr>
+        <p:spPr>
+          <a:xfrm>
+            <a:off x="457200" y="2478024"/>
+            <a:ext cx="128016" cy="1051560"/>
+          </a:xfrm>
+          <a:prstGeom prst="rect">
+            <a:avLst/>
+          </a:prstGeom>
+          <a:solidFill>
+            <a:srgbClr val="FFD000"/>
+          </a:solidFill>
+          <a:ln>
+            <a:noFill/>
+          </a:ln>
+        </p:spPr>
+        <p:style>
+          <a:lnRef idx="1">
+            <a:schemeClr val="accent1"/>
+          </a:lnRef>
+          <a:fillRef idx="3">
+            <a:schemeClr val="accent1"/>
+          </a:fillRef>
+          <a:effectRef idx="2">
+            <a:schemeClr val="accent1"/>
+          </a:effectRef>
+          <a:fontRef idx="minor">
+            <a:schemeClr val="lt1"/>
+          </a:fontRef>
+        </p:style>
+        <p:txBody>
+          <a:bodyPr rtlCol="0" anchor="ctr"/>
+          <a:lstStyle/>
+          <a:p>
+            <a:pPr algn="ctr"/>
+          </a:p>
+        </p:txBody>
+      </p:sp>
+      <p:sp>
+        <p:nvSpPr>
+          <p:cNvPr id="10" name="TextBox 9"/>
+          <p:cNvSpPr txBox="1"/>
+          <p:nvPr/>
+        </p:nvSpPr>
+        <p:spPr>
+          <a:xfrm>
+            <a:off x="777240" y="2615184"/>
+            <a:ext cx="10774375" cy="822959"/>
+          </a:xfrm>
+          <a:prstGeom prst="rect">
+            <a:avLst/>
+          </a:prstGeom>
+          <a:noFill/>
+        </p:spPr>
+        <p:txBody>
+          <a:bodyPr wrap="square">
+            <a:spAutoFit/>
+          </a:bodyPr>
+          <a:lstStyle/>
+          <a:p>
+            <a:r>
+              <a:rPr sz="1200" b="1" i="0">
+                <a:solidFill>
+                  <a:srgbClr val="FFD000"/>
+                </a:solidFill>
+                <a:latin typeface="Calibri"/>
+              </a:rPr>
+              <a:t>Aclaración</a:t>
+            </a:r>
+          </a:p>
+          <a:p>
+            <a:pPr>
+              <a:spcBef>
+                <a:spcPts val="400"/>
+              </a:spcBef>
+            </a:pPr>
+            <a:r>
+              <a:rPr sz="1400" b="0" i="0">
                 <a:solidFill>
                   <a:srgbClr val="333333"/>
                 </a:solidFill>
                 <a:latin typeface="Calibri"/>
               </a:rPr>
-              <a:t> Paso 1: liste los 6 elementos de costo de su diseno tomandolos del C4Deployment de la Clase 7 (edge, API, worker, base de datos, almacen de objetos y minutos de integracion continua), verificando que no aparezca ningun componente que no exista en su diagrama y que ninguno quede sin fila, porque al ser clase autonoma nadie va a completar la tabla por usted.</a:t>
+              <a:t>Subir evidencias al paquete CloudLite (Drive/repo) y a ExamLab (https://uniaj.examlab.workers.dev/) domingo 23:59.</a:t>
+            </a:r>
+          </a:p>
+        </p:txBody>
+      </p:sp>
+      <p:sp>
+        <p:nvSpPr>
+          <p:cNvPr id="11" name="Rounded Rectangle 10"/>
+          <p:cNvSpPr/>
+          <p:nvPr/>
+        </p:nvSpPr>
+        <p:spPr>
+          <a:xfrm>
+            <a:off x="457200" y="3694176"/>
+            <a:ext cx="11277295" cy="1051560"/>
+          </a:xfrm>
+          <a:prstGeom prst="roundRect">
+            <a:avLst>
+              <a:gd name="adj" fmla="val 12000"/>
+            </a:avLst>
+          </a:prstGeom>
+          <a:solidFill>
+            <a:srgbClr val="FBE4E4"/>
+          </a:solidFill>
+          <a:ln>
+            <a:noFill/>
+          </a:ln>
+        </p:spPr>
+        <p:style>
+          <a:lnRef idx="1">
+            <a:schemeClr val="accent1"/>
+          </a:lnRef>
+          <a:fillRef idx="3">
+            <a:schemeClr val="accent1"/>
+          </a:fillRef>
+          <a:effectRef idx="2">
+            <a:schemeClr val="accent1"/>
+          </a:effectRef>
+          <a:fontRef idx="minor">
+            <a:schemeClr val="lt1"/>
+          </a:fontRef>
+        </p:style>
+        <p:txBody>
+          <a:bodyPr rtlCol="0" anchor="ctr"/>
+          <a:lstStyle/>
+          <a:p>
+            <a:pPr algn="ctr"/>
+          </a:p>
+        </p:txBody>
+      </p:sp>
+      <p:sp>
+        <p:nvSpPr>
+          <p:cNvPr id="12" name="Rectangle 11"/>
+          <p:cNvSpPr/>
+          <p:nvPr/>
+        </p:nvSpPr>
+        <p:spPr>
+          <a:xfrm>
+            <a:off x="457200" y="3694176"/>
+            <a:ext cx="128016" cy="1051560"/>
+          </a:xfrm>
+          <a:prstGeom prst="rect">
+            <a:avLst/>
+          </a:prstGeom>
+          <a:solidFill>
+            <a:srgbClr val="A02030"/>
+          </a:solidFill>
+          <a:ln>
+            <a:noFill/>
+          </a:ln>
+        </p:spPr>
+        <p:style>
+          <a:lnRef idx="1">
+            <a:schemeClr val="accent1"/>
+          </a:lnRef>
+          <a:fillRef idx="3">
+            <a:schemeClr val="accent1"/>
+          </a:fillRef>
+          <a:effectRef idx="2">
+            <a:schemeClr val="accent1"/>
+          </a:effectRef>
+          <a:fontRef idx="minor">
+            <a:schemeClr val="lt1"/>
+          </a:fontRef>
+        </p:style>
+        <p:txBody>
+          <a:bodyPr rtlCol="0" anchor="ctr"/>
+          <a:lstStyle/>
+          <a:p>
+            <a:pPr algn="ctr"/>
+          </a:p>
+        </p:txBody>
+      </p:sp>
+      <p:sp>
+        <p:nvSpPr>
+          <p:cNvPr id="13" name="TextBox 12"/>
+          <p:cNvSpPr txBox="1"/>
+          <p:nvPr/>
+        </p:nvSpPr>
+        <p:spPr>
+          <a:xfrm>
+            <a:off x="777240" y="3831336"/>
+            <a:ext cx="10774375" cy="822959"/>
+          </a:xfrm>
+          <a:prstGeom prst="rect">
+            <a:avLst/>
+          </a:prstGeom>
+          <a:noFill/>
+        </p:spPr>
+        <p:txBody>
+          <a:bodyPr wrap="square">
+            <a:spAutoFit/>
+          </a:bodyPr>
+          <a:lstStyle/>
+          <a:p>
+            <a:r>
+              <a:rPr sz="1200" b="1" i="0">
+                <a:solidFill>
+                  <a:srgbClr val="A02030"/>
+                </a:solidFill>
+                <a:latin typeface="Calibri"/>
+              </a:rPr>
+              <a:t>Atención</a:t>
             </a:r>
           </a:p>
           <a:p>
             <a:pPr>
-              <a:spcAft>
-                <a:spcPts val="800"/>
-              </a:spcAft>
+              <a:spcBef>
+                <a:spcPts val="400"/>
+              </a:spcBef>
             </a:pPr>
             <a:r>
-              <a:rPr sz="1600" b="0" i="0">
+              <a:rPr sz="1400" b="0" i="0">
                 <a:solidFill>
                   <a:srgbClr val="333333"/>
                 </a:solidFill>
                 <a:latin typeface="Calibri"/>
               </a:rPr>
-              <a:t>–   </a:t>
-            </a:r>
-            <a:r>
-              <a:rPr sz="1600" b="1" i="0">
-                <a:solidFill>
-                  <a:srgbClr val="333333"/>
-                </a:solidFill>
-                <a:latin typeface="Calibri"/>
-              </a:rPr>
-              <a:t>2.</a:t>
-            </a:r>
-            <a:r>
-              <a:rPr sz="1600" b="0" i="0">
-                <a:solidFill>
-                  <a:srgbClr val="333333"/>
-                </a:solidFill>
-                <a:latin typeface="Calibri"/>
-              </a:rPr>
-              <a:t> Paso 2: complete la tabla de 5 columnas asignando a cada elemento su driver de costo, el nivel bajo, medio o alto, un apalancamiento y el riesgo de aplicarlo, verificando que ningun driver se repita entre filas y que la palabra caro no aparezca sola como explicacion.</a:t>
-            </a:r>
-          </a:p>
-          <a:p>
-            <a:pPr>
-              <a:spcAft>
-                <a:spcPts val="800"/>
-              </a:spcAft>
-            </a:pPr>
-            <a:r>
-              <a:rPr sz="1600" b="0" i="0">
-                <a:solidFill>
-                  <a:srgbClr val="333333"/>
-                </a:solidFill>
-                <a:latin typeface="Calibri"/>
-              </a:rPr>
-              <a:t>–   </a:t>
-            </a:r>
-            <a:r>
-              <a:rPr sz="1600" b="1" i="0">
-                <a:solidFill>
-                  <a:srgbClr val="333333"/>
-                </a:solidFill>
-                <a:latin typeface="Calibri"/>
-              </a:rPr>
-              <a:t>3.</a:t>
-            </a:r>
-            <a:r>
-              <a:rPr sz="1600" b="0" i="0">
-                <a:solidFill>
-                  <a:srgbClr val="333333"/>
-                </a:solidFill>
-                <a:latin typeface="Calibri"/>
-              </a:rPr>
-              <a:t> Paso 3: escriba en ExamLab el mindmap Mermaid con las 5 ramas de drivers (computo, datos, transferencia, ocioso e integracion continua) y 2 hojas concretas por rama, verificando al renderizar que las 10 hojas mencionen elementos reales de su despliegue y no categorias abstractas.</a:t>
-            </a:r>
-          </a:p>
-          <a:p>
-            <a:pPr>
-              <a:spcAft>
-                <a:spcPts val="800"/>
-              </a:spcAft>
-            </a:pPr>
-            <a:r>
-              <a:rPr sz="1600" b="0" i="0">
-                <a:solidFill>
-                  <a:srgbClr val="333333"/>
-                </a:solidFill>
-                <a:latin typeface="Calibri"/>
-              </a:rPr>
-              <a:t>–   </a:t>
-            </a:r>
-            <a:r>
-              <a:rPr sz="1600" b="1" i="0">
-                <a:solidFill>
-                  <a:srgbClr val="333333"/>
-                </a:solidFill>
-                <a:latin typeface="Calibri"/>
-              </a:rPr>
-              <a:t>4.</a:t>
-            </a:r>
-            <a:r>
-              <a:rPr sz="1600" b="0" i="0">
-                <a:solidFill>
-                  <a:srgbClr val="333333"/>
-                </a:solidFill>
-                <a:latin typeface="Calibri"/>
-              </a:rPr>
-              <a:t> Paso 4: desarrolle 3 apalancamientos de ahorro con su estado antes y despues y 3 acciones de sostenibilidad verificables, verificando que cada accion tenga una evidencia que un tercero pueda revisar (tamano de la imagen en megabytes, hora de apagado del lab, numero de replicas en la noche) y que ninguna rompa un requisito del PI.</a:t>
-            </a:r>
-          </a:p>
-          <a:p>
-            <a:pPr>
-              <a:spcAft>
-                <a:spcPts val="800"/>
-              </a:spcAft>
-            </a:pPr>
-            <a:r>
-              <a:rPr sz="1600" b="0" i="0">
-                <a:solidFill>
-                  <a:srgbClr val="333333"/>
-                </a:solidFill>
-                <a:latin typeface="Calibri"/>
-              </a:rPr>
-              <a:t>–   </a:t>
-            </a:r>
-            <a:r>
-              <a:rPr sz="1600" b="1" i="0">
-                <a:solidFill>
-                  <a:srgbClr val="333333"/>
-                </a:solidFill>
-                <a:latin typeface="Calibri"/>
-              </a:rPr>
-              <a:t>5.</a:t>
-            </a:r>
-            <a:r>
-              <a:rPr sz="1600" b="0" i="0">
-                <a:solidFill>
-                  <a:srgbClr val="333333"/>
-                </a:solidFill>
-                <a:latin typeface="Calibri"/>
-              </a:rPr>
-              <a:t> Paso 5: integre la tabla, el mindmap y las acciones en la seccion Costos y sostenibilidad del informe (1 pagina) y suba las 5 preguntas a ExamLab (modulo Talleres) antes del domingo 23:59, verificando que no haya inventado ninguna factura en dolares de un proveedor de pago.</a:t>
-            </a:r>
-          </a:p>
-        </p:txBody>
-      </p:sp>
-      <p:sp>
-        <p:nvSpPr>
-          <p:cNvPr id="6" name="TextBox 5"/>
+              <a:t>Sin cloud de pago ni instalaciones obligatorias de hipervisores/Docker Desktop.</a:t>
+            </a:r>
+          </a:p>
+        </p:txBody>
+      </p:sp>
+      <p:sp>
+        <p:nvSpPr>
+          <p:cNvPr id="14" name="TextBox 13"/>
           <p:cNvSpPr txBox="1"/>
           <p:nvPr/>
         </p:nvSpPr>

</xml_diff>